<commit_message>
docs(deck): plain titles, agenda slide, app link, much less text
- 13 slides: adds an Agenda right after the title, listing every section
  under the names they were asked for
- every h2 is now the plain section name; the clever headlines are gone
- text cut hard throughout: notes and ledes deleted or reduced to one line,
  card bodies to a single short sentence; numbers kept
- Live demo slide gets a large link to the deployed app in place of the
  curl block and the long caption
- runsheet reworked for 13 slides and the new clock
</commit_message>
<xml_diff>
--- a/docs/Valentin-TFC.pptx
+++ b/docs/Valentin-TFC.pptx
@@ -17,6 +17,7 @@
     <p:sldId id="265" r:id="rId17"/>
     <p:sldId id="266" r:id="rId18"/>
     <p:sldId id="267" r:id="rId19"/>
+    <p:sldId id="268" r:id="rId20"/>
   </p:sldIdLst>
   <p:sldSz cx="12191695" cy="6858000" type="screen4x3"/>
   <p:notesSz cx="6858000" cy="9144000"/>
@@ -513,7 +514,7 @@
           <a:lstStyle/>
           <a:p>
             <a:r>
-              <a:t>ROMANTIC CONCIERGE · GENAI TFC PROJECT</a:t>
+              <a:t>GENAI TFC PROJECT</a:t>
             </a:r>
           </a:p>
           <a:p>
@@ -523,7 +524,7 @@
           </a:p>
           <a:p>
             <a:r>
-              <a:t>He remembers everything she mentioned once — including the date you keep forgetting.</a:t>
+              <a:t>A romantic concierge agent, built twice — once by hand, once on Bedrock AgentCore.</a:t>
             </a:r>
           </a:p>
           <a:p>
@@ -534,11 +535,6 @@
           <a:p>
             <a:r>
               <a:t>Technical Account Manager, AWS</a:t>
-            </a:r>
-          </a:p>
-          <a:p>
-            <a:r>
-              <a:t>Built by six AI agents, on two engines, in us-east-1</a:t>
             </a:r>
           </a:p>
           <a:p>
@@ -613,182 +609,112 @@
           <a:lstStyle/>
           <a:p>
             <a:r>
-              <a:t>10 · HOW IT WAS BUILT · THE TEAM</a:t>
-            </a:r>
-          </a:p>
-          <a:p>
-            <a:r>
-              <a:t>I didn't write it. They did.</a:t>
-            </a:r>
-          </a:p>
-          <a:p>
-            <a:r>
-              <a:t>CM</a:t>
-            </a:r>
-          </a:p>
-          <a:p>
-            <a:r>
-              <a:t>Coral · human</a:t>
-            </a:r>
-          </a:p>
-          <a:p>
-            <a:r>
-              <a:t>Product intent, final say, veto. Wrote none of the application code.</a:t>
-            </a:r>
-          </a:p>
-          <a:p>
-            <a:r>
-              <a:t>Master Agent .kiro/ · .github/</a:t>
-            </a:r>
-          </a:p>
-          <a:p>
-            <a:r>
-              <a:t>Decomposes, delegates, reviews, merges — and posts the last word.</a:t>
-            </a:r>
-          </a:p>
-          <a:p>
-            <a:r>
-              <a:t>#37 orchestrator-led PR review loop with multi-agent tagging</a:t>
-            </a:r>
-          </a:p>
-          <a:p>
-            <a:r>
-              <a:t>#19 iterative PR conversations after Ready for Review</a:t>
-            </a:r>
-          </a:p>
-          <a:p>
-            <a:r>
-              <a:t>8 hooks plus the pre-merge conversation gate</a:t>
-            </a:r>
-          </a:p>
-          <a:p>
-            <a:r>
-              <a:t>System Architectsrc/shared/</a:t>
-            </a:r>
-          </a:p>
-          <a:p>
-            <a:r>
-              <a:t>Contracts and shared types. Writes the spec before anyone branches.</a:t>
-            </a:r>
-          </a:p>
-          <a:p>
-            <a:r>
-              <a:t>#2 shared types, validation, persistence, design tokens</a:t>
-            </a:r>
-          </a:p>
-          <a:p>
-            <a:r>
-              <a:t>#41 category lookup helpers</a:t>
-            </a:r>
-          </a:p>
-          <a:p>
-            <a:r>
-              <a:t>#44 preferenceCategoryCount</a:t>
-            </a:r>
-          </a:p>
-          <a:p>
-            <a:r>
-              <a:t>Frontend Devsrc/client/</a:t>
-            </a:r>
-          </a:p>
-          <a:p>
-            <a:r>
-              <a:t>Components, hooks, state. Cannot touch shared types.</a:t>
-            </a:r>
-          </a:p>
-          <a:p>
-            <a:r>
-              <a:t>#3 chat UI, profile dashboard, state management</a:t>
-            </a:r>
-          </a:p>
-          <a:p>
-            <a:r>
-              <a:t>#58 Partner Profile Panel — 27 files</a:t>
-            </a:r>
-          </a:p>
-          <a:p>
-            <a:r>
-              <a:t>#65 Valentin Inspector, a live architecture slide-over</a:t>
-            </a:r>
-          </a:p>
-          <a:p>
-            <a:r>
-              <a:t>Backend Devsrc/server/</a:t>
-            </a:r>
-          </a:p>
-          <a:p>
-            <a:r>
-              <a:t>API, Bedrock extraction, persistence. Cannot touch the client.</a:t>
-            </a:r>
-          </a:p>
-          <a:p>
-            <a:r>
-              <a:t>#4 API layer, orchestrator, preference extractor</a:t>
-            </a:r>
-          </a:p>
-          <a:p>
-            <a:r>
-              <a:t>#15 real AWS Bedrock SDK integration</a:t>
-            </a:r>
-          </a:p>
-          <a:p>
-            <a:r>
-              <a:t>#123 the Spotify dev-mode endpoints</a:t>
-            </a:r>
-          </a:p>
-          <a:p>
-            <a:r>
-              <a:t>UI Designerdesign-system/</a:t>
-            </a:r>
-          </a:p>
-          <a:p>
-            <a:r>
-              <a:t>Tokens, accessibility, and eight real mockups to choose from.</a:t>
-            </a:r>
-          </a:p>
-          <a:p>
-            <a:r>
-              <a:t>#16 refined palette and gradient accents</a:t>
-            </a:r>
-          </a:p>
-          <a:p>
-            <a:r>
-              <a:t>#22 polished component pass</a:t>
-            </a:r>
-          </a:p>
-          <a:p>
-            <a:r>
-              <a:t>8 full mockups, one of them shipped</a:t>
-            </a:r>
-          </a:p>
-          <a:p>
-            <a:r>
-              <a:t>QA Agente2e/</a:t>
-            </a:r>
-          </a:p>
-          <a:p>
-            <a:r>
-              <a:t>Playwright E2E and regression coverage. Cannot touch src at all.</a:t>
-            </a:r>
-          </a:p>
-          <a:p>
-            <a:r>
-              <a:t>#8 onboarding, responsive, connection-recovery suites</a:t>
-            </a:r>
-          </a:p>
-          <a:p>
-            <a:r>
-              <a:t>5 PRs reviewed purely for coverage</a:t>
-            </a:r>
-          </a:p>
-          <a:p>
-            <a:r>
-              <a:t>376 tests green before any merge</a:t>
-            </a:r>
-          </a:p>
-          <a:p>
-            <a:r>
-              <a:t>Each is a prompt file with a voice exemplar and an explicit do-not-modify list — disjoint ownership is what makes five agents editing at once something other than a merge-conflict generator. Control advances by a call, never by hope: the master reviews, tags the owners in one comment, invokes them, and waits for each to return. My first design was event-led, and nothing moved — the loop had no engine.</a:t>
+              <a:t>10 · COMPARISON · SECURITY</a:t>
+            </a:r>
+          </a:p>
+          <a:p>
+            <a:r>
+              <a:t>Comparison — Security</a:t>
+            </a:r>
+          </a:p>
+          <a:p>
+            <a:r>
+              <a:t>One guardrail, both engines. The work was tuning it — the safe default broke the product.</a:t>
+            </a:r>
+          </a:p>
+          <a:p>
+            <a:r>
+              <a:t>6</a:t>
+            </a:r>
+          </a:p>
+          <a:p>
+            <a:r>
+              <a:t>content filters, measured</a:t>
+            </a:r>
+          </a:p>
+          <a:p>
+            <a:r>
+              <a:t>At HIGH, SEXUAL blocked "her ring size is 6" — a field the agent asks for.</a:t>
+            </a:r>
+          </a:p>
+          <a:p>
+            <a:r>
+              <a:t>5</a:t>
+            </a:r>
+          </a:p>
+          <a:p>
+            <a:r>
+              <a:t>PII entities blocked</a:t>
+            </a:r>
+          </a:p>
+          <a:p>
+            <a:r>
+              <a:t>Card, SSN, phone, and both AWS key types.</a:t>
+            </a:r>
+          </a:p>
+          <a:p>
+            <a:r>
+              <a:t>3</a:t>
+            </a:r>
+          </a:p>
+          <a:p>
+            <a:r>
+              <a:t>regexes replacing one entity</a:t>
+            </a:r>
+          </a:p>
+          <a:p>
+            <a:r>
+              <a:t>ADDRESS read "saving for Kyoto" as an address.</a:t>
+            </a:r>
+          </a:p>
+          <a:p>
+            <a:r>
+              <a:t>7</a:t>
+            </a:r>
+          </a:p>
+          <a:p>
+            <a:r>
+              <a:t>tools that cannot act alone</a:t>
+            </a:r>
+          </a:p>
+          <a:p>
+            <a:r>
+              <a:t>Every write awaits a human yes.</a:t>
+            </a:r>
+          </a:p>
+          <a:p>
+            <a:r>
+              <a:t>Known gap · ALB listener is HTTP</a:t>
+            </a:r>
+          </a:p>
+          <a:p>
+            <a:r>
+              <a:t>TLS terminates at CloudFront; the hop to the ALB doesn't.</a:t>
+            </a:r>
+          </a:p>
+          <a:p>
+            <a:r>
+              <a:t>Known gap · Cognito isn't enforced</a:t>
+            </a:r>
+          </a:p>
+          <a:p>
+            <a:r>
+              <a:t>The front door is a demo login, not a real one.</a:t>
+            </a:r>
+          </a:p>
+          <a:p>
+            <a:r>
+              <a:t>Known gap · secrets by hand</a:t>
+            </a:r>
+          </a:p>
+          <a:p>
+            <a:r>
+              <a:t>Populating Google OAuth is still manual after a deploy.</a:t>
+            </a:r>
+          </a:p>
+          <a:p>
+            <a:r>
+              <a:t>NAME, AGE and EMAIL are deliberately not blocked — they are this agent's subject matter. Every decision is a dated comment in safety-stack.ts.</a:t>
             </a:r>
           </a:p>
         </p:txBody>
@@ -858,87 +784,92 @@
           <a:lstStyle/>
           <a:p>
             <a:r>
-              <a:t>11 · HOW IT WAS BUILT · THE PULL REQUESTS</a:t>
-            </a:r>
-          </a:p>
-          <a:p>
-            <a:r>
-              <a:t>Every node is a real pull request.</a:t>
-            </a:r>
-          </a:p>
-          <a:p>
-            <a:r>
-              <a:t>57</a:t>
-            </a:r>
-          </a:p>
-          <a:p>
-            <a:r>
-              <a:t>pull requests</a:t>
-            </a:r>
-          </a:p>
-          <a:p>
-            <a:r>
-              <a:t>49 merged, 7 closed without merging. At the peak, five were open at once.</a:t>
-            </a:r>
-          </a:p>
-          <a:p>
-            <a:r>
-              <a:t>176</a:t>
-            </a:r>
-          </a:p>
-          <a:p>
-            <a:r>
-              <a:t>commits</a:t>
-            </a:r>
-          </a:p>
-          <a:p>
-            <a:r>
-              <a:t>+35,531 lines added, −1,963 removed, across 438 files touched.</a:t>
-            </a:r>
-          </a:p>
-          <a:p>
-            <a:r>
-              <a:t>93</a:t>
-            </a:r>
-          </a:p>
-          <a:p>
-            <a:r>
-              <a:t>review comments</a:t>
-            </a:r>
-          </a:p>
-          <a:p>
-            <a:r>
-              <a:t>The two longest threads run dozens deep — and they argue.</a:t>
-            </a:r>
-          </a:p>
-          <a:p>
-            <a:r>
-              <a:t>32</a:t>
-            </a:r>
-          </a:p>
-          <a:p>
-            <a:r>
-              <a:t>workflow PRs</a:t>
-            </a:r>
-          </a:p>
-          <a:p>
-            <a:r>
-              <a:t>The biggest lane is the methodology itself, not the app.</a:t>
-            </a:r>
-          </a:p>
-          <a:p>
-            <a:r>
-              <a:t>"Accept your reasoning — at current scale this is not a performance concern. Non-blocking."</a:t>
-            </a:r>
-          </a:p>
-          <a:p>
-            <a:r>
-              <a:t>MASTER AGENT → FRONTEND DEV · PR #58, AFTER BEING PUSHED BACK ON</a:t>
-            </a:r>
-          </a:p>
-          <a:p>
-            <a:r>
-              <a:t>Generated from the repo's PR history, so it can't drift. Node size is files changed; rings mean a genuine multi-agent review thread; hollow dashed nodes were closed without merging. A refused merge is a feature — the gate checks four pure, unit-tested conditions and says no if any fails. Approval is a comment token, because GitHub returns 422 if you approve your own PR and every agent here is one account.</a:t>
+              <a:t>11 · HOW IT WAS BUILT · THE AGENT TEAM</a:t>
+            </a:r>
+          </a:p>
+          <a:p>
+            <a:r>
+              <a:t>How it was built — the agent team</a:t>
+            </a:r>
+          </a:p>
+          <a:p>
+            <a:r>
+              <a:t>CM</a:t>
+            </a:r>
+          </a:p>
+          <a:p>
+            <a:r>
+              <a:t>Coral · human</a:t>
+            </a:r>
+          </a:p>
+          <a:p>
+            <a:r>
+              <a:t>Product intent, final say, veto. Wrote none of the application code.</a:t>
+            </a:r>
+          </a:p>
+          <a:p>
+            <a:r>
+              <a:t>Master Agent .kiro/ · .github/</a:t>
+            </a:r>
+          </a:p>
+          <a:p>
+            <a:r>
+              <a:t>Decomposes, delegates, reviews, merges — and posts the last word.</a:t>
+            </a:r>
+          </a:p>
+          <a:p>
+            <a:r>
+              <a:t>System Architectsrc/shared/</a:t>
+            </a:r>
+          </a:p>
+          <a:p>
+            <a:r>
+              <a:t>Contracts and shared types. Writes the spec before anyone branches.</a:t>
+            </a:r>
+          </a:p>
+          <a:p>
+            <a:r>
+              <a:t>Frontend Devsrc/client/</a:t>
+            </a:r>
+          </a:p>
+          <a:p>
+            <a:r>
+              <a:t>Components, hooks, state. Cannot touch shared types.</a:t>
+            </a:r>
+          </a:p>
+          <a:p>
+            <a:r>
+              <a:t>Backend Devsrc/server/</a:t>
+            </a:r>
+          </a:p>
+          <a:p>
+            <a:r>
+              <a:t>API, extraction, persistence. Cannot touch the client.</a:t>
+            </a:r>
+          </a:p>
+          <a:p>
+            <a:r>
+              <a:t>UI Designerdesign-system/</a:t>
+            </a:r>
+          </a:p>
+          <a:p>
+            <a:r>
+              <a:t>Tokens and accessibility. Eight mockups, one shipped.</a:t>
+            </a:r>
+          </a:p>
+          <a:p>
+            <a:r>
+              <a:t>QA Agente2e/</a:t>
+            </a:r>
+          </a:p>
+          <a:p>
+            <a:r>
+              <a:t>Playwright E2E. Cannot touch src at all.</a:t>
+            </a:r>
+          </a:p>
+          <a:p>
+            <a:r>
+              <a:t>Disjoint ownership is what makes five agents editing at once something other than a merge-conflict generator.</a:t>
             </a:r>
           </a:p>
         </p:txBody>
@@ -1008,12 +939,152 @@
           <a:lstStyle/>
           <a:p>
             <a:r>
-              <a:t>12 · CONCLUSIONS</a:t>
-            </a:r>
-          </a:p>
-          <a:p>
-            <a:r>
-              <a:t>Four things I didn't know going in.</a:t>
+              <a:t>12 · HOW IT WAS BUILT · THE PRS GRAPH</a:t>
+            </a:r>
+          </a:p>
+          <a:p>
+            <a:r>
+              <a:t>How it was built — the PRs graph</a:t>
+            </a:r>
+          </a:p>
+          <a:p>
+            <a:r>
+              <a:t>57</a:t>
+            </a:r>
+          </a:p>
+          <a:p>
+            <a:r>
+              <a:t>pull requests</a:t>
+            </a:r>
+          </a:p>
+          <a:p>
+            <a:r>
+              <a:t>49 merged, 7 closed without merging.</a:t>
+            </a:r>
+          </a:p>
+          <a:p>
+            <a:r>
+              <a:t>176</a:t>
+            </a:r>
+          </a:p>
+          <a:p>
+            <a:r>
+              <a:t>commits</a:t>
+            </a:r>
+          </a:p>
+          <a:p>
+            <a:r>
+              <a:t>+35,531 lines, 438 files touched.</a:t>
+            </a:r>
+          </a:p>
+          <a:p>
+            <a:r>
+              <a:t>93</a:t>
+            </a:r>
+          </a:p>
+          <a:p>
+            <a:r>
+              <a:t>review comments</a:t>
+            </a:r>
+          </a:p>
+          <a:p>
+            <a:r>
+              <a:t>The two longest threads argue.</a:t>
+            </a:r>
+          </a:p>
+          <a:p>
+            <a:r>
+              <a:t>32</a:t>
+            </a:r>
+          </a:p>
+          <a:p>
+            <a:r>
+              <a:t>workflow PRs</a:t>
+            </a:r>
+          </a:p>
+          <a:p>
+            <a:r>
+              <a:t>The biggest lane is the methodology, not the app.</a:t>
+            </a:r>
+          </a:p>
+          <a:p>
+            <a:r>
+              <a:t>Generated from the repo's PR history, so it can't drift.</a:t>
+            </a:r>
+          </a:p>
+        </p:txBody>
+      </p:sp>
+      <p:sp>
+        <p:nvSpPr>
+          <p:cNvPr id="4" name="Slide Number Placeholder 3"/>
+          <p:cNvSpPr>
+            <a:spLocks noGrp="1"/>
+          </p:cNvSpPr>
+          <p:nvPr>
+            <p:ph type="sldNum" idx="5" sz="quarter"/>
+          </p:nvPr>
+        </p:nvSpPr>
+        <p:spPr/>
+      </p:sp>
+    </p:spTree>
+  </p:cSld>
+  <p:clrMapOvr>
+    <a:masterClrMapping/>
+  </p:clrMapOvr>
+</p:notes>
+</file>
+
+<file path=ppt/notesSlides/notesSlide13.xml><?xml version="1.0" encoding="utf-8"?>
+<p:notes xmlns:a="http://schemas.openxmlformats.org/drawingml/2006/main" xmlns:p="http://schemas.openxmlformats.org/presentationml/2006/main" xmlns:r="http://schemas.openxmlformats.org/officeDocument/2006/relationships">
+  <p:cSld>
+    <p:spTree>
+      <p:nvGrpSpPr>
+        <p:cNvPr id="1" name=""/>
+        <p:cNvGrpSpPr/>
+        <p:nvPr/>
+      </p:nvGrpSpPr>
+      <p:grpSpPr>
+        <a:xfrm>
+          <a:off x="0" y="0"/>
+          <a:ext cx="0" cy="0"/>
+          <a:chOff x="0" y="0"/>
+          <a:chExt cx="0" cy="0"/>
+        </a:xfrm>
+      </p:grpSpPr>
+      <p:sp>
+        <p:nvSpPr>
+          <p:cNvPr id="2" name="Slide Image Placeholder 1"/>
+          <p:cNvSpPr>
+            <a:spLocks noGrp="1"/>
+          </p:cNvSpPr>
+          <p:nvPr>
+            <p:ph type="sldImg" idx="2"/>
+          </p:nvPr>
+        </p:nvSpPr>
+        <p:spPr/>
+      </p:sp>
+      <p:sp>
+        <p:nvSpPr>
+          <p:cNvPr id="3" name="Notes Placeholder 2"/>
+          <p:cNvSpPr>
+            <a:spLocks noGrp="1"/>
+          </p:cNvSpPr>
+          <p:nvPr>
+            <p:ph type="body" idx="3" sz="quarter"/>
+          </p:nvPr>
+        </p:nvSpPr>
+        <p:spPr/>
+        <p:txBody>
+          <a:bodyPr/>
+          <a:lstStyle/>
+          <a:p>
+            <a:r>
+              <a:t>13 · LESSONS LEARNED</a:t>
+            </a:r>
+          </a:p>
+          <a:p>
+            <a:r>
+              <a:t>Lessons learned</a:t>
             </a:r>
           </a:p>
           <a:p>
@@ -1028,7 +1099,7 @@
           </a:p>
           <a:p>
             <a:r>
-              <a:t>32 of 57 PRs and +13,425 lines went into the agents, hooks, router and merge gate — more than the application itself. If you try this, budget for building the process, not just the thing the process makes.</a:t>
+              <a:t>32 of 57 PRs went into the agents, hooks and merge gate. Budget for building the process.</a:t>
             </a:r>
           </a:p>
           <a:p>
@@ -1043,7 +1114,7 @@
           </a:p>
           <a:p>
             <a:r>
-              <a:t>The cost table is the loud slide and the weaker argument — the ratio collapses from 187× to 13.5× once fixed costs amortise. The durable win is one microVM per session: the same fault that takes out forty sessions on Fargate takes out one.</a:t>
+              <a:t>187× collapses to 13.5× once fixed costs amortise. The durable win is one microVM per session.</a:t>
             </a:r>
           </a:p>
           <a:p>
@@ -1058,7 +1129,7 @@
           </a:p>
           <a:p>
             <a:r>
-              <a:t>When an agent got stuck in a loop, more of the same model didn't help — a stronger model writing the plan did, then a weaker one executing each step. Model choice is a per-phase decision, not a per-project one.</a:t>
+              <a:t>Stuck in a loop, more of the same model didn't help — a stronger planner did. Model choice is per-phase.</a:t>
             </a:r>
           </a:p>
           <a:p>
@@ -1073,12 +1144,7 @@
           </a:p>
           <a:p>
             <a:r>
-              <a:t>Engine B was green for weeks and had never served a turn. CREATE_COMPLETE, a healthy Runtime, and a proxy logging invoke ok: true — while the container returned its failures as a 200 with an empty body. Four faults, each hiding the next.</a:t>
-            </a:r>
-          </a:p>
-          <a:p>
-            <a:r>
-              <a:t>Honest scope, since it's the part worth trusting: the orchestrator-led loop, the turn router, the eight hooks and the merge gate are real, unit-tested and exercised across the whole PR history. The agent labels are convention applied in a batch, not a wired-up hook. And engine B's isolation is what the Runtime offers — this deployment still answers through one shared proxy task. Every claim here is checkable: the methodology writeup, the generated graph, and all 57 PR conversations.</a:t>
+              <a:t>Engine B was green for weeks and had never served a turn. Four faults, each hiding the next.</a:t>
             </a:r>
           </a:p>
           <a:p>
@@ -1088,7 +1154,7 @@
           </a:p>
           <a:p>
             <a:r>
-              <a:t>Happy to open any PR, walk the turn router, or run the demo on someone you love</a:t>
+              <a:t>Happy to open any PR or run the demo</a:t>
             </a:r>
           </a:p>
         </p:txBody>
@@ -1158,67 +1224,122 @@
           <a:lstStyle/>
           <a:p>
             <a:r>
-              <a:t>02 · USE CASE</a:t>
-            </a:r>
-          </a:p>
-          <a:p>
-            <a:r>
-              <a:t>The date isn't the hard part. Remembering is.</a:t>
-            </a:r>
-          </a:p>
-          <a:p>
-            <a:r>
-              <a:t>You know her anniversary is somewhere in March. You know she mentioned a restaurant once, and that she doesn't eat fish. None of it is written down anywhere, and the gap between caring about someone and actually planning something is pure admin — which is exactly the thing that gets dropped.</a:t>
-            </a:r>
-          </a:p>
-          <a:p>
-            <a:r>
-              <a:t>THE PROBLEM</a:t>
-            </a:r>
-          </a:p>
-          <a:p>
-            <a:r>
-              <a:t>The details arrive in conversation</a:t>
-            </a:r>
-          </a:p>
-          <a:p>
-            <a:r>
-              <a:t>Nobody fills in an eighteen-field questionnaire about their partner, and the details worth keeping aren't fields anyway — they're mentioned in passing, once, months before they matter.</a:t>
-            </a:r>
-          </a:p>
-          <a:p>
-            <a:r>
-              <a:t>WHY A REMINDER APP DOESN'T FIX IT</a:t>
-            </a:r>
-          </a:p>
-          <a:p>
-            <a:r>
-              <a:t>"Anniversary" on the day is useless</a:t>
-            </a:r>
-          </a:p>
-          <a:p>
-            <a:r>
-              <a:t>By then every good table is gone. What you needed was lead time you chose, and options you could act on in one tap — not a notification telling you you're already late.</a:t>
-            </a:r>
-          </a:p>
-          <a:p>
-            <a:r>
-              <a:t>WHAT IT ACTUALLY IS</a:t>
-            </a:r>
-          </a:p>
-          <a:p>
-            <a:r>
-              <a:t>Extract, remember, act later</a:t>
-            </a:r>
-          </a:p>
-          <a:p>
-            <a:r>
-              <a:t>Long-lived preference extraction, a durable profile, and a time-triggered outbound action. Romance is the demo. The pattern is onboarding, renewals and account-health follow-up.</a:t>
-            </a:r>
-          </a:p>
-          <a:p>
-            <a:r>
-              <a:t>The agent test — why this needs an agent and not a form with a cron job: the input is unstructured and arrives over weeks, the plan needs several tools in an order that depends on what came back (is that Friday a Shabbat? is the table free? is she vegetarian?), and a human has to stay in the loop before anything is booked or sent. No fixed decision tree survives that.</a:t>
+              <a:t>02 · AGENDA</a:t>
+            </a:r>
+          </a:p>
+          <a:p>
+            <a:r>
+              <a:t>Agenda</a:t>
+            </a:r>
+          </a:p>
+          <a:p>
+            <a:r>
+              <a:t>01</a:t>
+            </a:r>
+          </a:p>
+          <a:p>
+            <a:r>
+              <a:t>Use case</a:t>
+            </a:r>
+          </a:p>
+          <a:p>
+            <a:r>
+              <a:t>07</a:t>
+            </a:r>
+          </a:p>
+          <a:p>
+            <a:r>
+              <a:t>Comparison — Resilience</a:t>
+            </a:r>
+          </a:p>
+          <a:p>
+            <a:r>
+              <a:t>02</a:t>
+            </a:r>
+          </a:p>
+          <a:p>
+            <a:r>
+              <a:t>What the app can do</a:t>
+            </a:r>
+          </a:p>
+          <a:p>
+            <a:r>
+              <a:t>08</a:t>
+            </a:r>
+          </a:p>
+          <a:p>
+            <a:r>
+              <a:t>Comparison — Security</a:t>
+            </a:r>
+          </a:p>
+          <a:p>
+            <a:r>
+              <a:t>03</a:t>
+            </a:r>
+          </a:p>
+          <a:p>
+            <a:r>
+              <a:t>Architecture</a:t>
+            </a:r>
+          </a:p>
+          <a:p>
+            <a:r>
+              <a:t>09</a:t>
+            </a:r>
+          </a:p>
+          <a:p>
+            <a:r>
+              <a:t>How it was built — the agent team</a:t>
+            </a:r>
+          </a:p>
+          <a:p>
+            <a:r>
+              <a:t>04</a:t>
+            </a:r>
+          </a:p>
+          <a:p>
+            <a:r>
+              <a:t>Live demo</a:t>
+            </a:r>
+          </a:p>
+          <a:p>
+            <a:r>
+              <a:t>10</a:t>
+            </a:r>
+          </a:p>
+          <a:p>
+            <a:r>
+              <a:t>How it was built — the PRs graph</a:t>
+            </a:r>
+          </a:p>
+          <a:p>
+            <a:r>
+              <a:t>05</a:t>
+            </a:r>
+          </a:p>
+          <a:p>
+            <a:r>
+              <a:t>Comparison — Cost</a:t>
+            </a:r>
+          </a:p>
+          <a:p>
+            <a:r>
+              <a:t>11</a:t>
+            </a:r>
+          </a:p>
+          <a:p>
+            <a:r>
+              <a:t>Lessons learned</a:t>
+            </a:r>
+          </a:p>
+          <a:p>
+            <a:r>
+              <a:t>06</a:t>
+            </a:r>
+          </a:p>
+          <a:p>
+            <a:r>
+              <a:t>Comparison — Tool use</a:t>
             </a:r>
           </a:p>
         </p:txBody>
@@ -1288,122 +1409,62 @@
           <a:lstStyle/>
           <a:p>
             <a:r>
-              <a:t>03 · WHAT THE APP CAN DO</a:t>
-            </a:r>
-          </a:p>
-          <a:p>
-            <a:r>
-              <a:t>Conversation in. A booked evening out.</a:t>
-            </a:r>
-          </a:p>
-          <a:p>
-            <a:r>
-              <a:t>So the interview is the interface. He asks like a person, the profile fills itself in as you talk, and then he comes back to you before you'd have thought of it yourself.</a:t>
-            </a:r>
-          </a:p>
-          <a:p>
-            <a:r>
-              <a:t>1</a:t>
-            </a:r>
-          </a:p>
-          <a:p>
-            <a:r>
-              <a:t>You talk about her</a:t>
-            </a:r>
-          </a:p>
-          <a:p>
-            <a:r>
-              <a:t>Session-scoped WebSocket to the orchestrator. Claude Sonnet 4.5 on Bedrock, in character, asking rather than interrogating.</a:t>
-            </a:r>
-          </a:p>
-          <a:p>
-            <a:r>
-              <a:t>2</a:t>
-            </a:r>
-          </a:p>
-          <a:p>
-            <a:r>
-              <a:t>The profile fills itself</a:t>
-            </a:r>
-          </a:p>
-          <a:p>
-            <a:r>
-              <a:t>A second Bedrock call extracts structured preferences off the reply's critical path — eight categories, every entry carrying a confidence score.</a:t>
-            </a:r>
-          </a:p>
-          <a:p>
-            <a:r>
-              <a:t>3</a:t>
-            </a:r>
-          </a:p>
-          <a:p>
-            <a:r>
-              <a:t>He keeps the dates</a:t>
-            </a:r>
-          </a:p>
-          <a:p>
-            <a:r>
-              <a:t>Important dates land on her file, and you choose the lead time — a month before, a week, a day.</a:t>
-            </a:r>
-          </a:p>
-          <a:p>
-            <a:r>
-              <a:t>4</a:t>
-            </a:r>
-          </a:p>
-          <a:p>
-            <a:r>
-              <a:t>The reminder arrives</a:t>
-            </a:r>
-          </a:p>
-          <a:p>
-            <a:r>
-              <a:t>Real email, with restaurants near her that match what he learned, a playlist for later, and a link back into the app to confirm.</a:t>
-            </a:r>
-          </a:p>
-          <a:p>
-            <a:r>
-              <a:t>Food</a:t>
-            </a:r>
-          </a:p>
-          <a:p>
-            <a:r>
-              <a:t>Hobbies</a:t>
-            </a:r>
-          </a:p>
-          <a:p>
-            <a:r>
-              <a:t>Music</a:t>
-            </a:r>
-          </a:p>
-          <a:p>
-            <a:r>
-              <a:t>Travel</a:t>
-            </a:r>
-          </a:p>
-          <a:p>
-            <a:r>
-              <a:t>Gifts</a:t>
-            </a:r>
-          </a:p>
-          <a:p>
-            <a:r>
-              <a:t>Love language</a:t>
-            </a:r>
-          </a:p>
-          <a:p>
-            <a:r>
-              <a:t>Important dates</a:t>
-            </a:r>
-          </a:p>
-          <a:p>
-            <a:r>
-              <a:t>Personality</a:t>
-            </a:r>
-          </a:p>
-          <a:p>
-            <a:r>
-              <a:t>React 19 + TS strict · Express 5 + ws · Bedrock Converse · DynamoDB behind a storage interface · CDK on ECS Fargate · Vitest + Playwright. Honest about the edges: the reminder really does send — REMINDER_CHANNEL=gmail is set on the deployed task — but it falls back to writing the mail into the log if that variable is missing, and the WhatsApp nudge is wired as a tool the guardrail currently blocks by design.</a:t>
+              <a:t>03 · USE CASE</a:t>
+            </a:r>
+          </a:p>
+          <a:p>
+            <a:r>
+              <a:t>Use case</a:t>
+            </a:r>
+          </a:p>
+          <a:p>
+            <a:r>
+              <a:t>THE PROBLEM</a:t>
+            </a:r>
+          </a:p>
+          <a:p>
+            <a:r>
+              <a:t>The details arrive in conversation</a:t>
+            </a:r>
+          </a:p>
+          <a:p>
+            <a:r>
+              <a:t>Mentioned once, in passing, months before they matter.</a:t>
+            </a:r>
+          </a:p>
+          <a:p>
+            <a:r>
+              <a:t>WHY A REMINDER APP ISN'T ENOUGH</a:t>
+            </a:r>
+          </a:p>
+          <a:p>
+            <a:r>
+              <a:t>"Anniversary" on the day is too late</a:t>
+            </a:r>
+          </a:p>
+          <a:p>
+            <a:r>
+              <a:t>You needed lead time you chose, and options you can act on.</a:t>
+            </a:r>
+          </a:p>
+          <a:p>
+            <a:r>
+              <a:t>THE PATTERN</a:t>
+            </a:r>
+          </a:p>
+          <a:p>
+            <a:r>
+              <a:t>Extract, remember, act later</a:t>
+            </a:r>
+          </a:p>
+          <a:p>
+            <a:r>
+              <a:t>Romance is the demo. The same shape fits onboarding and renewals.</a:t>
+            </a:r>
+          </a:p>
+          <a:p>
+            <a:r>
+              <a:t>Why an agent and not a form with a cron job: unstructured input arriving over weeks, a plan whose next tool depends on what came back, and a human in the loop before anything sends.</a:t>
             </a:r>
           </a:p>
         </p:txBody>
@@ -1473,67 +1534,112 @@
           <a:lstStyle/>
           <a:p>
             <a:r>
-              <a:t>04 · ARCHITECTURE</a:t>
-            </a:r>
-          </a:p>
-          <a:p>
-            <a:r>
-              <a:t>One product, two engines, one diagram.</a:t>
-            </a:r>
-          </a:p>
-          <a:p>
-            <a:r>
-              <a:t>Same agent, built twice, both running behind one URL and switchable from the UI. Same persona, same model, same reply call — so every difference belongs to the platform.</a:t>
-            </a:r>
-          </a:p>
-          <a:p>
-            <a:r>
-              <a:t>ENGINE A · GLUE CODE I WROTE  →  ENGINE B · AGENTCORE</a:t>
-            </a:r>
-          </a:p>
-          <a:p>
-            <a:r>
-              <a:t>ECS Fargate → Runtime</a:t>
-            </a:r>
-          </a:p>
-          <a:p>
-            <a:r>
-              <a:t>one always-on task → one microVM per session</a:t>
-            </a:r>
-          </a:p>
-          <a:p>
-            <a:r>
-              <a:t>DynamoDB → Memory</a:t>
-            </a:r>
-          </a:p>
-          <a:p>
-            <a:r>
-              <a:t>my store and schema → a managed strategy</a:t>
-            </a:r>
-          </a:p>
-          <a:p>
-            <a:r>
-              <a:t>A 2nd Bedrock call → Memory</a:t>
-            </a:r>
-          </a:p>
-          <a:p>
-            <a:r>
-              <a:t>my extraction pass → extraction I don't write</a:t>
-            </a:r>
-          </a:p>
-          <a:p>
-            <a:r>
-              <a:t>In-process registry → Gateway</a:t>
-            </a:r>
-          </a:p>
-          <a:p>
-            <a:r>
-              <a:t>functions in the task → tools over MCP, on Lambda</a:t>
-            </a:r>
-          </a:p>
-          <a:p>
-            <a:r>
-              <a:t>Every box exists in us-east-1. Bedrock, the guardrail and one DynamoDB table are held fixed across both lanes — that's what makes a delta attributable to the orchestration layer rather than to a different model.</a:t>
+              <a:t>04 · WHAT THE APP CAN DO</a:t>
+            </a:r>
+          </a:p>
+          <a:p>
+            <a:r>
+              <a:t>What the app can do</a:t>
+            </a:r>
+          </a:p>
+          <a:p>
+            <a:r>
+              <a:t>1</a:t>
+            </a:r>
+          </a:p>
+          <a:p>
+            <a:r>
+              <a:t>You talk about her</a:t>
+            </a:r>
+          </a:p>
+          <a:p>
+            <a:r>
+              <a:t>Claude Sonnet 4.5 on Bedrock, in character.</a:t>
+            </a:r>
+          </a:p>
+          <a:p>
+            <a:r>
+              <a:t>2</a:t>
+            </a:r>
+          </a:p>
+          <a:p>
+            <a:r>
+              <a:t>The profile fills itself</a:t>
+            </a:r>
+          </a:p>
+          <a:p>
+            <a:r>
+              <a:t>A second Bedrock call extracts preferences into eight categories.</a:t>
+            </a:r>
+          </a:p>
+          <a:p>
+            <a:r>
+              <a:t>3</a:t>
+            </a:r>
+          </a:p>
+          <a:p>
+            <a:r>
+              <a:t>He keeps the dates</a:t>
+            </a:r>
+          </a:p>
+          <a:p>
+            <a:r>
+              <a:t>You choose the lead time — a month, a week, a day.</a:t>
+            </a:r>
+          </a:p>
+          <a:p>
+            <a:r>
+              <a:t>4</a:t>
+            </a:r>
+          </a:p>
+          <a:p>
+            <a:r>
+              <a:t>The reminder arrives</a:t>
+            </a:r>
+          </a:p>
+          <a:p>
+            <a:r>
+              <a:t>Real email: restaurants that match, a playlist, a link to confirm.</a:t>
+            </a:r>
+          </a:p>
+          <a:p>
+            <a:r>
+              <a:t>Food</a:t>
+            </a:r>
+          </a:p>
+          <a:p>
+            <a:r>
+              <a:t>Hobbies</a:t>
+            </a:r>
+          </a:p>
+          <a:p>
+            <a:r>
+              <a:t>Music</a:t>
+            </a:r>
+          </a:p>
+          <a:p>
+            <a:r>
+              <a:t>Travel</a:t>
+            </a:r>
+          </a:p>
+          <a:p>
+            <a:r>
+              <a:t>Gifts</a:t>
+            </a:r>
+          </a:p>
+          <a:p>
+            <a:r>
+              <a:t>Love language</a:t>
+            </a:r>
+          </a:p>
+          <a:p>
+            <a:r>
+              <a:t>Important dates</a:t>
+            </a:r>
+          </a:p>
+          <a:p>
+            <a:r>
+              <a:t>Personality</a:t>
             </a:r>
           </a:p>
         </p:txBody>
@@ -1603,57 +1709,62 @@
           <a:lstStyle/>
           <a:p>
             <a:r>
-              <a:t>05 · LIVE DEMO</a:t>
-            </a:r>
-          </a:p>
-          <a:p>
-            <a:r>
-              <a:t>Let's just look at it.</a:t>
-            </a:r>
-          </a:p>
-          <a:p>
-            <a:r>
-              <a:t>Tell him about someone you love. He asks like a person, not a form — and the panel on the right fills itself in as you talk.</a:t>
-            </a:r>
-          </a:p>
-          <a:p>
-            <a:r>
-              <a:t>Open the deployed app ↗</a:t>
-            </a:r>
-          </a:p>
-          <a:p>
-            <a:r>
-              <a:t>CloudFront → ALB → Fargate, us-east-1</a:t>
-            </a:r>
-          </a:p>
-          <a:p>
-            <a:r>
-              <a:t>$ curl -s .../api/health</a:t>
-            </a:r>
-          </a:p>
-          <a:p>
-            <a:r>
-              <a:t>{"status":"healthy","environment":"production"}</a:t>
-            </a:r>
-          </a:p>
-          <a:p>
-            <a:r>
-              <a:t>Watch for. A name and a birthday landing at 100% confidence within four messages; the richer categories arriving a beat later.</a:t>
-            </a:r>
-          </a:p>
-          <a:p>
-            <a:r>
-              <a:t>Then. Ask him to plan something — he checks Shabbat times and restaurant availability in the same turn, then offers a card rather than booking.</a:t>
-            </a:r>
-          </a:p>
-          <a:p>
-            <a:r>
-              <a:t>The switch. Same conversation, flipped to engine B from the UI.</a:t>
-            </a:r>
-          </a:p>
-          <a:p>
-            <a:r>
-              <a:t>Live on real infrastructure: seven CDK stacks the agents wrote from nothing, Fargate behind an ALB autoscaling 1→4, CloudFront + WAF at 2 000 req/IP. There's a demo login on the front door.</a:t>
+              <a:t>05 · ARCHITECTURE</a:t>
+            </a:r>
+          </a:p>
+          <a:p>
+            <a:r>
+              <a:t>Architecture</a:t>
+            </a:r>
+          </a:p>
+          <a:p>
+            <a:r>
+              <a:t>One URL, two engines, switchable from the UI. Same model, same guardrail, same table — so every difference is the platform.</a:t>
+            </a:r>
+          </a:p>
+          <a:p>
+            <a:r>
+              <a:t>ENGINE A · MY GLUE CODE  →  ENGINE B · AGENTCORE</a:t>
+            </a:r>
+          </a:p>
+          <a:p>
+            <a:r>
+              <a:t>ECS Fargate → Runtime</a:t>
+            </a:r>
+          </a:p>
+          <a:p>
+            <a:r>
+              <a:t>one always-on task → one microVM per session</a:t>
+            </a:r>
+          </a:p>
+          <a:p>
+            <a:r>
+              <a:t>DynamoDB → Memory</a:t>
+            </a:r>
+          </a:p>
+          <a:p>
+            <a:r>
+              <a:t>my store → a managed strategy</a:t>
+            </a:r>
+          </a:p>
+          <a:p>
+            <a:r>
+              <a:t>A 2nd Bedrock call → Memory</a:t>
+            </a:r>
+          </a:p>
+          <a:p>
+            <a:r>
+              <a:t>my extraction pass → extraction I don't write</a:t>
+            </a:r>
+          </a:p>
+          <a:p>
+            <a:r>
+              <a:t>In-process registry → Gateway</a:t>
+            </a:r>
+          </a:p>
+          <a:p>
+            <a:r>
+              <a:t>functions → tools over MCP, on Lambda</a:t>
             </a:r>
           </a:p>
         </p:txBody>
@@ -1723,177 +1834,37 @@
           <a:lstStyle/>
           <a:p>
             <a:r>
-              <a:t>06 · COMPARISON · COST</a:t>
-            </a:r>
-          </a:p>
-          <a:p>
-            <a:r>
-              <a:t>Two bills, split into what's fixed and what grows.</a:t>
-            </a:r>
-          </a:p>
-          <a:p>
-            <a:r>
-              <a:t>Every rate from a vendor pricing page, every quantity counted out of this repo. The reply call to Bedrock is identical on both sides, so it's excluded from both.</a:t>
-            </a:r>
-          </a:p>
-          <a:p>
-            <a:r>
-              <a:t>ENGINE A · GLUE CODE</a:t>
-            </a:r>
-          </a:p>
-          <a:p>
-            <a:r>
-              <a:t>$18.02 fixed, $1.386 per user</a:t>
-            </a:r>
-          </a:p>
-          <a:p>
-            <a:r>
-              <a:t>AWS Fargate</a:t>
-            </a:r>
-          </a:p>
-          <a:p>
-            <a:r>
-              <a:t>0.5 vCPU · 730 h · never scales below 1</a:t>
-            </a:r>
-          </a:p>
-          <a:p>
-            <a:r>
-              <a:t>$18.02</a:t>
-            </a:r>
-          </a:p>
-          <a:p>
-            <a:r>
-              <a:t>2nd Bedrock extraction</a:t>
-            </a:r>
-          </a:p>
-          <a:p>
-            <a:r>
-              <a:t>104 turns × $0.01332</a:t>
-            </a:r>
-          </a:p>
-          <a:p>
-            <a:r>
-              <a:t>$1.385</a:t>
-            </a:r>
-          </a:p>
-          <a:p>
-            <a:r>
-              <a:t>Amazon DynamoDB</a:t>
-            </a:r>
-          </a:p>
-          <a:p>
-            <a:r>
-              <a:t>on-demand reads, writes, storage</a:t>
-            </a:r>
-          </a:p>
-          <a:p>
-            <a:r>
-              <a:t>$0.0006</a:t>
-            </a:r>
-          </a:p>
-          <a:p>
-            <a:r>
-              <a:t>At one user, per month</a:t>
-            </a:r>
-          </a:p>
-          <a:p>
-            <a:r>
-              <a:t>$19.41</a:t>
-            </a:r>
-          </a:p>
-          <a:p>
-            <a:r>
-              <a:t>VS</a:t>
-            </a:r>
-          </a:p>
-          <a:p>
-            <a:r>
-              <a:t>ENGINE B · AGENTCORE</a:t>
-            </a:r>
-          </a:p>
-          <a:p>
-            <a:r>
-              <a:t>$0.0006 fixed, $0.103 per user</a:t>
-            </a:r>
-          </a:p>
-          <a:p>
-            <a:r>
-              <a:t>AgentCore Gateway</a:t>
-            </a:r>
-          </a:p>
-          <a:p>
-            <a:r>
-              <a:t>tools indexed — the only fixed line</a:t>
-            </a:r>
-          </a:p>
-          <a:p>
-            <a:r>
-              <a:t>$0.0006</a:t>
-            </a:r>
-          </a:p>
-          <a:p>
-            <a:r>
-              <a:t>AgentCore Memory</a:t>
-            </a:r>
-          </a:p>
-          <a:p>
-            <a:r>
-              <a:t>1 event + 1 retrieval per turn, extraction included</a:t>
-            </a:r>
-          </a:p>
-          <a:p>
-            <a:r>
-              <a:t>$0.098</a:t>
-            </a:r>
-          </a:p>
-          <a:p>
-            <a:r>
-              <a:t>AgentCore Runtime</a:t>
-            </a:r>
-          </a:p>
-          <a:p>
-            <a:r>
-              <a:t>3 s × 104 turns, per-second billing</a:t>
-            </a:r>
-          </a:p>
-          <a:p>
-            <a:r>
-              <a:t>$0.0047</a:t>
-            </a:r>
-          </a:p>
-          <a:p>
-            <a:r>
-              <a:t>At one user, per month</a:t>
-            </a:r>
-          </a:p>
-          <a:p>
-            <a:r>
-              <a:t>$0.10</a:t>
-            </a:r>
-          </a:p>
-          <a:p>
-            <a:r>
-              <a:t>USERS	ENGINE A	ENGINE B	RATIO	SAVED / MONTH</a:t>
-            </a:r>
-          </a:p>
-          <a:p>
-            <a:r>
-              <a:t>1	$19.41	$0.10	187×	$19</a:t>
-            </a:r>
-          </a:p>
-          <a:p>
-            <a:r>
-              <a:t>10,000	$13,877	$1,029	13.5×	$12,848</a:t>
-            </a:r>
-          </a:p>
-          <a:p>
-            <a:r>
-              <a:t>1,000,000	$1.39 M	$103 k	13.5×	$1.28 M</a:t>
-            </a:r>
-          </a:p>
-          <a:p>
-            <a:r>
-              <a:t>The last two columns move in opposite directions: the ratio falls from 187× to 13.5× as Fargate's fixed $18 amortises, while the money grows without limit — about $15.4 M a year at a million users. AgentCore loses on unit price (Runtime 2.20× dearer per hour, Memory ~124× per turn) and wins on billing granularity. And if Memory meters retrievals per record rather than per call, engine B becomes 3.8× worse — confirm with the service team before quoting any of this. scripts/cost-model.mjs reproduces every figure.</a:t>
+              <a:t>06 · LIVE DEMO</a:t>
+            </a:r>
+          </a:p>
+          <a:p>
+            <a:r>
+              <a:t>Live demo</a:t>
+            </a:r>
+          </a:p>
+          <a:p>
+            <a:r>
+              <a:t>Open Valentin ↗</a:t>
+            </a:r>
+          </a:p>
+          <a:p>
+            <a:r>
+              <a:t>d26dwovftfq9oe.cloudfront.net</a:t>
+            </a:r>
+          </a:p>
+          <a:p>
+            <a:r>
+              <a:t>Watch the panel. Name and birthday at 100% confidence within four messages.</a:t>
+            </a:r>
+          </a:p>
+          <a:p>
+            <a:r>
+              <a:t>Then ask him to plan. Shabbat times and table availability in one turn — then a card to confirm, not a booking.</a:t>
+            </a:r>
+          </a:p>
+          <a:p>
+            <a:r>
+              <a:t>The switch. Same conversation, flipped to engine B.</a:t>
             </a:r>
           </a:p>
         </p:txBody>
@@ -1963,127 +1934,77 @@
           <a:lstStyle/>
           <a:p>
             <a:r>
-              <a:t>07 · COMPARISON · TOOL USE</a:t>
-            </a:r>
-          </a:p>
-          <a:p>
-            <a:r>
-              <a:t>The same twenty tools, reached two different ways.</a:t>
-            </a:r>
-          </a:p>
-          <a:p>
-            <a:r>
-              <a:t>This is the part that makes it an agent rather than a chatbot: it can look the world up, and it can offer to act on it. The tool surface is identical on both engines — how the agent is allowed to reach it is not.</a:t>
-            </a:r>
-          </a:p>
-          <a:p>
-            <a:r>
-              <a:t>20</a:t>
-            </a:r>
-          </a:p>
-          <a:p>
-            <a:r>
-              <a:t>tools, ten integrations</a:t>
-            </a:r>
-          </a:p>
-          <a:p>
-            <a:r>
-              <a:t>Ontopo · Amadeus · Google Calendar, Gmail and Places · Spotify · web search · a page reader · Hebcal · Wolt · WhatsApp. Live APIs, not stubs.</a:t>
-            </a:r>
-          </a:p>
-          <a:p>
-            <a:r>
-              <a:t>13</a:t>
-            </a:r>
-          </a:p>
-          <a:p>
-            <a:r>
-              <a:t>that only look things up</a:t>
-            </a:r>
-          </a:p>
-          <a:p>
-            <a:r>
-              <a:t>Availability, Shabbat times, Hebrew dates, places nearby, music. The agent plans around real constraints instead of inventing them.</a:t>
-            </a:r>
-          </a:p>
-          <a:p>
-            <a:r>
-              <a:t>7</a:t>
-            </a:r>
-          </a:p>
-          <a:p>
-            <a:r>
-              <a:t>that propose, never act</a:t>
-            </a:r>
-          </a:p>
-          <a:p>
-            <a:r>
-              <a:t>Every propose_* tool returns a card she confirms. It drafts the email and books nothing — a human is in the loop by construction.</a:t>
-            </a:r>
-          </a:p>
-          <a:p>
-            <a:r>
-              <a:t>5</a:t>
-            </a:r>
-          </a:p>
-          <a:p>
-            <a:r>
-              <a:t>model round-trips per turn</a:t>
-            </a:r>
-          </a:p>
-          <a:p>
-            <a:r>
-              <a:t>MAX_TOOL_ITERATIONS. It calls a tool, reads the result, and decides again — and it can ask for several at once, resolved concurrently.</a:t>
-            </a:r>
-          </a:p>
-          <a:p>
-            <a:r>
-              <a:t>ENGINE A · IN-PROCESS</a:t>
-            </a:r>
-          </a:p>
-          <a:p>
-            <a:r>
-              <a:t>A registry inside the task</a:t>
-            </a:r>
-          </a:p>
-          <a:p>
-            <a:r>
-              <a:t>Tools are TypeScript functions</a:t>
-            </a:r>
-          </a:p>
-          <a:p>
-            <a:r>
-              <a:t>called directly in the Node process</a:t>
-            </a:r>
-          </a:p>
-          <a:p>
-            <a:r>
-              <a:t>No authorization boundary</a:t>
-            </a:r>
-          </a:p>
-          <a:p>
-            <a:r>
-              <a:t>anything in the task can call anything</a:t>
-            </a:r>
-          </a:p>
-          <a:p>
-            <a:r>
-              <a:t>Adding a tool</a:t>
-            </a:r>
-          </a:p>
-          <a:p>
-            <a:r>
-              <a:t>redeploy the container</a:t>
-            </a:r>
-          </a:p>
-          <a:p>
-            <a:r>
-              <a:t>Fast and simple</a:t>
-            </a:r>
-          </a:p>
-          <a:p>
-            <a:r>
-              <a:t>no network hop, no schema to keep in sync</a:t>
+              <a:t>07 · COMPARISON · COST</a:t>
+            </a:r>
+          </a:p>
+          <a:p>
+            <a:r>
+              <a:t>Comparison — Cost</a:t>
+            </a:r>
+          </a:p>
+          <a:p>
+            <a:r>
+              <a:t>ENGINE A · GLUE CODE</a:t>
+            </a:r>
+          </a:p>
+          <a:p>
+            <a:r>
+              <a:t>$18.02 fixed, $1.386 per user</a:t>
+            </a:r>
+          </a:p>
+          <a:p>
+            <a:r>
+              <a:t>AWS Fargate</a:t>
+            </a:r>
+          </a:p>
+          <a:p>
+            <a:r>
+              <a:t>never scales below 1</a:t>
+            </a:r>
+          </a:p>
+          <a:p>
+            <a:r>
+              <a:t>$18.02</a:t>
+            </a:r>
+          </a:p>
+          <a:p>
+            <a:r>
+              <a:t>2nd Bedrock extraction</a:t>
+            </a:r>
+          </a:p>
+          <a:p>
+            <a:r>
+              <a:t>104 turns</a:t>
+            </a:r>
+          </a:p>
+          <a:p>
+            <a:r>
+              <a:t>$1.385</a:t>
+            </a:r>
+          </a:p>
+          <a:p>
+            <a:r>
+              <a:t>Amazon DynamoDB</a:t>
+            </a:r>
+          </a:p>
+          <a:p>
+            <a:r>
+              <a:t>on-demand</a:t>
+            </a:r>
+          </a:p>
+          <a:p>
+            <a:r>
+              <a:t>$0.0006</a:t>
+            </a:r>
+          </a:p>
+          <a:p>
+            <a:r>
+              <a:t>At one user, per month</a:t>
+            </a:r>
+          </a:p>
+          <a:p>
+            <a:r>
+              <a:t>$19.41</a:t>
             </a:r>
           </a:p>
           <a:p>
@@ -2093,57 +2014,92 @@
           </a:p>
           <a:p>
             <a:r>
-              <a:t>ENGINE B · GATEWAY OVER MCP</a:t>
-            </a:r>
-          </a:p>
-          <a:p>
-            <a:r>
-              <a:t>A contract the platform owns</a:t>
-            </a:r>
-          </a:p>
-          <a:p>
-            <a:r>
-              <a:t>Two Lambda targets</a:t>
-            </a:r>
-          </a:p>
-          <a:p>
-            <a:r>
-              <a:t>3 profile tools + 20 integration tools</a:t>
-            </a:r>
-          </a:p>
-          <a:p>
-            <a:r>
-              <a:t>CUSTOM_JWT authorizer</a:t>
-            </a:r>
-          </a:p>
-          <a:p>
-            <a:r>
-              <a:t>scoped to exactly two machine clients</a:t>
-            </a:r>
-          </a:p>
-          <a:p>
-            <a:r>
-              <a:t>Adding a tool</a:t>
-            </a:r>
-          </a:p>
-          <a:p>
-            <a:r>
-              <a:t>regenerate schemas, update the stack</a:t>
-            </a:r>
-          </a:p>
-          <a:p>
-            <a:r>
-              <a:t>A hop, and a real seam</a:t>
-            </a:r>
-          </a:p>
-          <a:p>
-            <a:r>
-              <a:t>the tool contract is reviewable, not implicit</a:t>
-            </a:r>
-          </a:p>
-          <a:p>
-            <a:r>
-              <a:t>The schemas engine B publishes are generated from the tools themselves by scripts/generate-tool-schemas.mts, so the two engines cannot drift apart — a tool added to engine A and forgotten in the Gateway is a build failure rather than a silently dark integration. That was learned the hard way: twice, a tool merged on main was missing from the Gateway's account. Honest edge — the WhatsApp nudge exists as a tool but the guardrail blocks PHONE, so that one path is deliberately unreachable today.</a:t>
+              <a:t>ENGINE B · AGENTCORE</a:t>
+            </a:r>
+          </a:p>
+          <a:p>
+            <a:r>
+              <a:t>$0.0006 fixed, $0.103 per user</a:t>
+            </a:r>
+          </a:p>
+          <a:p>
+            <a:r>
+              <a:t>AgentCore Gateway</a:t>
+            </a:r>
+          </a:p>
+          <a:p>
+            <a:r>
+              <a:t>the only fixed line</a:t>
+            </a:r>
+          </a:p>
+          <a:p>
+            <a:r>
+              <a:t>$0.0006</a:t>
+            </a:r>
+          </a:p>
+          <a:p>
+            <a:r>
+              <a:t>AgentCore Memory</a:t>
+            </a:r>
+          </a:p>
+          <a:p>
+            <a:r>
+              <a:t>extraction included</a:t>
+            </a:r>
+          </a:p>
+          <a:p>
+            <a:r>
+              <a:t>$0.098</a:t>
+            </a:r>
+          </a:p>
+          <a:p>
+            <a:r>
+              <a:t>AgentCore Runtime</a:t>
+            </a:r>
+          </a:p>
+          <a:p>
+            <a:r>
+              <a:t>per-second billing</a:t>
+            </a:r>
+          </a:p>
+          <a:p>
+            <a:r>
+              <a:t>$0.0047</a:t>
+            </a:r>
+          </a:p>
+          <a:p>
+            <a:r>
+              <a:t>At one user, per month</a:t>
+            </a:r>
+          </a:p>
+          <a:p>
+            <a:r>
+              <a:t>$0.10</a:t>
+            </a:r>
+          </a:p>
+          <a:p>
+            <a:r>
+              <a:t>USERS	ENGINE A	ENGINE B	RATIO	SAVED / MONTH</a:t>
+            </a:r>
+          </a:p>
+          <a:p>
+            <a:r>
+              <a:t>1	$19.41	$0.10	187×	$19</a:t>
+            </a:r>
+          </a:p>
+          <a:p>
+            <a:r>
+              <a:t>10,000	$13,877	$1,029	13.5×	$12,848</a:t>
+            </a:r>
+          </a:p>
+          <a:p>
+            <a:r>
+              <a:t>1,000,000	$1.39 M	$103 k	13.5×	$1.28 M</a:t>
+            </a:r>
+          </a:p>
+          <a:p>
+            <a:r>
+              <a:t>The ratio falls as Fargate's fixed $18 amortises; the money keeps growing.</a:t>
             </a:r>
           </a:p>
         </p:txBody>
@@ -2213,47 +2169,112 @@
           <a:lstStyle/>
           <a:p>
             <a:r>
-              <a:t>08 · COMPARISON · RESILIENCE</a:t>
-            </a:r>
-          </a:p>
-          <a:p>
-            <a:r>
-              <a:t>One fault. Forty sessions.</a:t>
-            </a:r>
-          </a:p>
-          <a:p>
-            <a:r>
-              <a:t>Cost is not the strongest argument for AgentCore — this is. Both sides are the same forty live sessions, one process-level fault injected into the same session on each.</a:t>
-            </a:r>
-          </a:p>
-          <a:p>
-            <a:r>
-              <a:t>ENGINE A</a:t>
-            </a:r>
-          </a:p>
-          <a:p>
-            <a:r>
-              <a:t>One Node process</a:t>
-            </a:r>
-          </a:p>
-          <a:p>
-            <a:r>
-              <a:t>Forty WebSockets in one Set, one heap, one event loop — attach-websocket.ts:31.</a:t>
-            </a:r>
-          </a:p>
-          <a:p>
-            <a:r>
-              <a:t>40</a:t>
-            </a:r>
-          </a:p>
-          <a:p>
-            <a:r>
-              <a:t>of 40 sessions lost</a:t>
-            </a:r>
-          </a:p>
-          <a:p>
-            <a:r>
-              <a:t>every user, and every partner profile in flight</a:t>
+              <a:t>08 · COMPARISON · TOOL USE</a:t>
+            </a:r>
+          </a:p>
+          <a:p>
+            <a:r>
+              <a:t>Comparison — Tool use</a:t>
+            </a:r>
+          </a:p>
+          <a:p>
+            <a:r>
+              <a:t>20</a:t>
+            </a:r>
+          </a:p>
+          <a:p>
+            <a:r>
+              <a:t>tools, ten integrations</a:t>
+            </a:r>
+          </a:p>
+          <a:p>
+            <a:r>
+              <a:t>Ontopo, Amadeus, Google, Spotify, Hebcal, Wolt. Live APIs.</a:t>
+            </a:r>
+          </a:p>
+          <a:p>
+            <a:r>
+              <a:t>13</a:t>
+            </a:r>
+          </a:p>
+          <a:p>
+            <a:r>
+              <a:t>that only look things up</a:t>
+            </a:r>
+          </a:p>
+          <a:p>
+            <a:r>
+              <a:t>It plans around real constraints instead of inventing them.</a:t>
+            </a:r>
+          </a:p>
+          <a:p>
+            <a:r>
+              <a:t>7</a:t>
+            </a:r>
+          </a:p>
+          <a:p>
+            <a:r>
+              <a:t>that propose, never act</a:t>
+            </a:r>
+          </a:p>
+          <a:p>
+            <a:r>
+              <a:t>Every write returns a card she confirms.</a:t>
+            </a:r>
+          </a:p>
+          <a:p>
+            <a:r>
+              <a:t>5</a:t>
+            </a:r>
+          </a:p>
+          <a:p>
+            <a:r>
+              <a:t>model round-trips per turn</a:t>
+            </a:r>
+          </a:p>
+          <a:p>
+            <a:r>
+              <a:t>Calls a tool, reads the result, decides again.</a:t>
+            </a:r>
+          </a:p>
+          <a:p>
+            <a:r>
+              <a:t>ENGINE A · IN-PROCESS</a:t>
+            </a:r>
+          </a:p>
+          <a:p>
+            <a:r>
+              <a:t>A registry inside the task</a:t>
+            </a:r>
+          </a:p>
+          <a:p>
+            <a:r>
+              <a:t>TypeScript functions</a:t>
+            </a:r>
+          </a:p>
+          <a:p>
+            <a:r>
+              <a:t>called in the Node process</a:t>
+            </a:r>
+          </a:p>
+          <a:p>
+            <a:r>
+              <a:t>No authorization boundary</a:t>
+            </a:r>
+          </a:p>
+          <a:p>
+            <a:r>
+              <a:t>anything can call anything</a:t>
+            </a:r>
+          </a:p>
+          <a:p>
+            <a:r>
+              <a:t>Adding a tool</a:t>
+            </a:r>
+          </a:p>
+          <a:p>
+            <a:r>
+              <a:t>redeploy the container</a:t>
             </a:r>
           </a:p>
           <a:p>
@@ -2263,77 +2284,47 @@
           </a:p>
           <a:p>
             <a:r>
-              <a:t>ENGINE B</a:t>
-            </a:r>
-          </a:p>
-          <a:p>
-            <a:r>
-              <a:t>One microVM per session</a:t>
-            </a:r>
-          </a:p>
-          <a:p>
-            <a:r>
-              <a:t>Forty sessions, forty isolated execution environments. The fault has nowhere to travel.</a:t>
-            </a:r>
-          </a:p>
-          <a:p>
-            <a:r>
-              <a:t>1</a:t>
-            </a:r>
-          </a:p>
-          <a:p>
-            <a:r>
-              <a:t>of 40 sessions lost</a:t>
-            </a:r>
-          </a:p>
-          <a:p>
-            <a:r>
-              <a:t>the other 39 never notice</a:t>
-            </a:r>
-          </a:p>
-          <a:p>
-            <a:r>
-              <a:t>Unhandled rejection</a:t>
-            </a:r>
-          </a:p>
-          <a:p>
-            <a:r>
-              <a:t>One turn throws without a handler; Node exits, taking all 40 sockets with it.</a:t>
-            </a:r>
-          </a:p>
-          <a:p>
-            <a:r>
-              <a:t>Out of memory</a:t>
-            </a:r>
-          </a:p>
-          <a:p>
-            <a:r>
-              <a:t>One runaway conversation exhausts the 1 GiB task. The OOM killer doesn't ask whose request it was.</a:t>
-            </a:r>
-          </a:p>
-          <a:p>
-            <a:r>
-              <a:t>Event-loop block</a:t>
-            </a:r>
-          </a:p>
-          <a:p>
-            <a:r>
-              <a:t>One synchronous hot spot stalls the single loop — the other 39 see the app stop.</a:t>
-            </a:r>
-          </a:p>
-          <a:p>
-            <a:r>
-              <a:t>Injection that pivots</a:t>
-            </a:r>
-          </a:p>
-          <a:p>
-            <a:r>
-              <a:t>Reaches a process-wide singleton — the Bedrock client, the tool registry — holding everyone's credentials.</a:t>
-            </a:r>
-          </a:p>
-          <a:p>
-            <a:r>
-              <a:t>Two limits, both real. Engine A does isolate per-user state (forUser) — one user's logic bug can't read another's data; what they share is the process. And engine B isn't fully isolated in this deployment either — it still answers through valentin-ac-proxy, one shared Fargate task holding the sockets. The right panel is what AgentCore Runtime gives you, not yet what this repo deploys.</a:t>
+              <a:t>ENGINE B · GATEWAY OVER MCP</a:t>
+            </a:r>
+          </a:p>
+          <a:p>
+            <a:r>
+              <a:t>A contract the platform owns</a:t>
+            </a:r>
+          </a:p>
+          <a:p>
+            <a:r>
+              <a:t>Two Lambda targets</a:t>
+            </a:r>
+          </a:p>
+          <a:p>
+            <a:r>
+              <a:t>behind a CUSTOM_JWT authorizer</a:t>
+            </a:r>
+          </a:p>
+          <a:p>
+            <a:r>
+              <a:t>Scoped credentials</a:t>
+            </a:r>
+          </a:p>
+          <a:p>
+            <a:r>
+              <a:t>the Gateway signs, not the agent</a:t>
+            </a:r>
+          </a:p>
+          <a:p>
+            <a:r>
+              <a:t>Adding a tool</a:t>
+            </a:r>
+          </a:p>
+          <a:p>
+            <a:r>
+              <a:t>regenerate schemas, update the stack</a:t>
+            </a:r>
+          </a:p>
+          <a:p>
+            <a:r>
+              <a:t>Schemas are generated from the tools, so the two engines cannot drift apart.</a:t>
             </a:r>
           </a:p>
         </p:txBody>
@@ -2403,77 +2394,17 @@
           <a:lstStyle/>
           <a:p>
             <a:r>
-              <a:t>09 · COMPARISON · SECURITY</a:t>
-            </a:r>
-          </a:p>
-          <a:p>
-            <a:r>
-              <a:t>One guardrail, both engines — and it's tuned, not switched on.</a:t>
-            </a:r>
-          </a:p>
-          <a:p>
-            <a:r>
-              <a:t>This app asks a stranger for another person's name, birthday and home address, stores them, and then mails them. The interesting security work wasn't turning a guardrail on; it was discovering that the safe default broke the product, and measuring where the line actually belongs.</a:t>
-            </a:r>
-          </a:p>
-          <a:p>
-            <a:r>
-              <a:t>6</a:t>
-            </a:r>
-          </a:p>
-          <a:p>
-            <a:r>
-              <a:t>content filters, measured</a:t>
-            </a:r>
-          </a:p>
-          <a:p>
-            <a:r>
-              <a:t>SEXUAL is MEDIUM on input, HIGH on output — at HIGH it blocked "her ring size is 6 and she is 5 foot 4", which is a profile field the agent asks for outright.</a:t>
-            </a:r>
-          </a:p>
-          <a:p>
-            <a:r>
-              <a:t>5</a:t>
-            </a:r>
-          </a:p>
-          <a:p>
-            <a:r>
-              <a:t>PII entities blocked</a:t>
-            </a:r>
-          </a:p>
-          <a:p>
-            <a:r>
-              <a:t>Card number, SSN, phone, AWS access key, AWS secret key. Nothing about remembering a birthday is a reason to carry a credential.</a:t>
-            </a:r>
-          </a:p>
-          <a:p>
-            <a:r>
-              <a:t>3</a:t>
-            </a:r>
-          </a:p>
-          <a:p>
-            <a:r>
-              <a:t>regexes replacing one entity</a:t>
-            </a:r>
-          </a:p>
-          <a:p>
-            <a:r>
-              <a:t>ADDRESS read "she's been saving for Kyoto" as an address. Three residence-shaped patterns block 42 Maple Street and let Paris through.</a:t>
-            </a:r>
-          </a:p>
-          <a:p>
-            <a:r>
-              <a:t>7</a:t>
-            </a:r>
-          </a:p>
-          <a:p>
-            <a:r>
-              <a:t>tools that cannot act alone</a:t>
-            </a:r>
-          </a:p>
-          <a:p>
-            <a:r>
-              <a:t>Every write — reservation, email, calendar, gift — is a proposal with an expiry, awaiting a human yes. The agent's own word is never sufficient authority.</a:t>
+              <a:t>09 · COMPARISON · RESILIENCE</a:t>
+            </a:r>
+          </a:p>
+          <a:p>
+            <a:r>
+              <a:t>Comparison — Resilience</a:t>
+            </a:r>
+          </a:p>
+          <a:p>
+            <a:r>
+              <a:t>Forty live sessions on each side. One process-level fault.</a:t>
             </a:r>
           </a:p>
           <a:p>
@@ -2483,12 +2414,22 @@
           </a:p>
           <a:p>
             <a:r>
-              <a:t>Trust inside the process</a:t>
-            </a:r>
-          </a:p>
-          <a:p>
-            <a:r>
-              <a:t>The guardrail is applied in my code, tools are function calls, and one compromised turn sits in the same heap as everyone's credentials. Per-user state is scoped by forUser; the process is not.</a:t>
+              <a:t>One Node process</a:t>
+            </a:r>
+          </a:p>
+          <a:p>
+            <a:r>
+              <a:t>Forty WebSockets, one heap, one event loop.</a:t>
+            </a:r>
+          </a:p>
+          <a:p>
+            <a:r>
+              <a:t>40</a:t>
+            </a:r>
+          </a:p>
+          <a:p>
+            <a:r>
+              <a:t>of 40 sessions lost</a:t>
             </a:r>
           </a:p>
           <a:p>
@@ -2503,47 +2444,67 @@
           </a:p>
           <a:p>
             <a:r>
-              <a:t>Boundaries the platform enforces</a:t>
-            </a:r>
-          </a:p>
-          <a:p>
-            <a:r>
-              <a:t>Same guardrail via bedrock:ApplyGuardrail, so the policy can't diverge. Tools sit behind a JWT-scoped Gateway, each session gets its own microVM, and the Gateway signs Lambda calls with its own role rather than the agent's.</a:t>
-            </a:r>
-          </a:p>
-          <a:p>
-            <a:r>
-              <a:t>Known gap · ALB listener is HTTP</a:t>
-            </a:r>
-          </a:p>
-          <a:p>
-            <a:r>
-              <a:t>TLS terminates at CloudFront; the hop to the ALB isn't encrypted. Fine for a demo, not for anything real.</a:t>
-            </a:r>
-          </a:p>
-          <a:p>
-            <a:r>
-              <a:t>Known gap · Cognito isn't enforced</a:t>
-            </a:r>
-          </a:p>
-          <a:p>
-            <a:r>
-              <a:t>The user pool exists and the Gateway uses it for machine auth, but the app's own front door is a demo login, not a real one.</a:t>
-            </a:r>
-          </a:p>
-          <a:p>
-            <a:r>
-              <a:t>Known gap · secrets by hand</a:t>
-            </a:r>
-          </a:p>
-          <a:p>
-            <a:r>
-              <a:t>Google OAuth lives in Secrets Manager deployed and .env locally, and populating it is still a manual step after a deploy.</a:t>
-            </a:r>
-          </a:p>
-          <a:p>
-            <a:r>
-              <a:t>The judgement call worth defending: NAME, AGE, ADDRESS and EMAIL are deliberately not blocked. They are this agent's subject matter — the first two facts it asks for, and a recipient address is a required argument to propose_email — and each is stored under its own owner's key. Anonymising them made the agent answer "{NAME} — that's lovely" seconds after being told her name. Every one of those decisions is a dated comment in infra/lib/safety-stack.ts with the sentence that failed and the guardrail run that proved it.</a:t>
+              <a:t>One microVM per session</a:t>
+            </a:r>
+          </a:p>
+          <a:p>
+            <a:r>
+              <a:t>Forty isolated execution environments.</a:t>
+            </a:r>
+          </a:p>
+          <a:p>
+            <a:r>
+              <a:t>1</a:t>
+            </a:r>
+          </a:p>
+          <a:p>
+            <a:r>
+              <a:t>of 40 sessions lost</a:t>
+            </a:r>
+          </a:p>
+          <a:p>
+            <a:r>
+              <a:t>Unhandled rejection</a:t>
+            </a:r>
+          </a:p>
+          <a:p>
+            <a:r>
+              <a:t>Node exits, taking all 40 sockets with it.</a:t>
+            </a:r>
+          </a:p>
+          <a:p>
+            <a:r>
+              <a:t>Out of memory</a:t>
+            </a:r>
+          </a:p>
+          <a:p>
+            <a:r>
+              <a:t>One runaway conversation exhausts the 1 GiB task.</a:t>
+            </a:r>
+          </a:p>
+          <a:p>
+            <a:r>
+              <a:t>Event-loop block</a:t>
+            </a:r>
+          </a:p>
+          <a:p>
+            <a:r>
+              <a:t>One hot spot stalls the single loop.</a:t>
+            </a:r>
+          </a:p>
+          <a:p>
+            <a:r>
+              <a:t>Injection that pivots</a:t>
+            </a:r>
+          </a:p>
+          <a:p>
+            <a:r>
+              <a:t>Reaches a singleton holding everyone's credentials.</a:t>
+            </a:r>
+          </a:p>
+          <a:p>
+            <a:r>
+              <a:t>Honest: this deployment still answers through one shared proxy task. The right panel is what Runtime gives you, not yet what this repo deploys.</a:t>
             </a:r>
           </a:p>
         </p:txBody>
@@ -5593,7 +5554,7 @@
       <p:grpSpPr/>
       <p:pic>
         <p:nvPicPr>
-          <p:cNvPr id="2" name="Picture 1" descr="10-team.png"/>
+          <p:cNvPr id="2" name="Picture 1" descr="10-security.png"/>
           <p:cNvPicPr>
             <a:picLocks noChangeAspect="1"/>
           </p:cNvPicPr>
@@ -5635,7 +5596,7 @@
       <p:grpSpPr/>
       <p:pic>
         <p:nvPicPr>
-          <p:cNvPr id="2" name="Picture 1" descr="11-graph.png"/>
+          <p:cNvPr id="2" name="Picture 1" descr="11-team.png"/>
           <p:cNvPicPr>
             <a:picLocks noChangeAspect="1"/>
           </p:cNvPicPr>
@@ -5677,7 +5638,49 @@
       <p:grpSpPr/>
       <p:pic>
         <p:nvPicPr>
-          <p:cNvPr id="2" name="Picture 1" descr="12-lessons.png"/>
+          <p:cNvPr id="2" name="Picture 1" descr="12-graph.png"/>
+          <p:cNvPicPr>
+            <a:picLocks noChangeAspect="1"/>
+          </p:cNvPicPr>
+          <p:nvPr/>
+        </p:nvPicPr>
+        <p:blipFill>
+          <a:blip r:embed="rId2"/>
+          <a:stretch>
+            <a:fillRect/>
+          </a:stretch>
+        </p:blipFill>
+        <p:spPr>
+          <a:xfrm>
+            <a:off x="0" y="0"/>
+            <a:ext cx="12191695" cy="6858000"/>
+          </a:xfrm>
+          <a:prstGeom prst="rect">
+            <a:avLst/>
+          </a:prstGeom>
+        </p:spPr>
+      </p:pic>
+    </p:spTree>
+  </p:cSld>
+  <p:clrMapOvr>
+    <a:masterClrMapping/>
+  </p:clrMapOvr>
+</p:sld>
+</file>
+
+<file path=ppt/slides/slide13.xml><?xml version="1.0" encoding="utf-8"?>
+<p:sld xmlns:a="http://schemas.openxmlformats.org/drawingml/2006/main" xmlns:p="http://schemas.openxmlformats.org/presentationml/2006/main" xmlns:r="http://schemas.openxmlformats.org/officeDocument/2006/relationships">
+  <p:cSld>
+    <p:spTree>
+      <p:nvGrpSpPr>
+        <p:cNvPr id="1" name=""/>
+        <p:cNvGrpSpPr/>
+        <p:nvPr/>
+      </p:nvGrpSpPr>
+      <p:grpSpPr/>
+      <p:pic>
+        <p:nvPicPr>
+          <p:cNvPr id="2" name="Picture 1" descr="13-lessons.png"/>
           <p:cNvPicPr>
             <a:picLocks noChangeAspect="1"/>
           </p:cNvPicPr>
@@ -5719,7 +5722,7 @@
       <p:grpSpPr/>
       <p:pic>
         <p:nvPicPr>
-          <p:cNvPr id="2" name="Picture 1" descr="02-usecase.png"/>
+          <p:cNvPr id="2" name="Picture 1" descr="02-agenda.png"/>
           <p:cNvPicPr>
             <a:picLocks noChangeAspect="1"/>
           </p:cNvPicPr>
@@ -5761,7 +5764,7 @@
       <p:grpSpPr/>
       <p:pic>
         <p:nvPicPr>
-          <p:cNvPr id="2" name="Picture 1" descr="03-what.png"/>
+          <p:cNvPr id="2" name="Picture 1" descr="03-usecase.png"/>
           <p:cNvPicPr>
             <a:picLocks noChangeAspect="1"/>
           </p:cNvPicPr>
@@ -5803,7 +5806,7 @@
       <p:grpSpPr/>
       <p:pic>
         <p:nvPicPr>
-          <p:cNvPr id="2" name="Picture 1" descr="04-architecture.png"/>
+          <p:cNvPr id="2" name="Picture 1" descr="04-what.png"/>
           <p:cNvPicPr>
             <a:picLocks noChangeAspect="1"/>
           </p:cNvPicPr>
@@ -5845,7 +5848,7 @@
       <p:grpSpPr/>
       <p:pic>
         <p:nvPicPr>
-          <p:cNvPr id="2" name="Picture 1" descr="05-demo.png"/>
+          <p:cNvPr id="2" name="Picture 1" descr="05-architecture.png"/>
           <p:cNvPicPr>
             <a:picLocks noChangeAspect="1"/>
           </p:cNvPicPr>
@@ -5887,7 +5890,7 @@
       <p:grpSpPr/>
       <p:pic>
         <p:nvPicPr>
-          <p:cNvPr id="2" name="Picture 1" descr="06-cost.png"/>
+          <p:cNvPr id="2" name="Picture 1" descr="06-demo.png"/>
           <p:cNvPicPr>
             <a:picLocks noChangeAspect="1"/>
           </p:cNvPicPr>
@@ -5929,7 +5932,7 @@
       <p:grpSpPr/>
       <p:pic>
         <p:nvPicPr>
-          <p:cNvPr id="2" name="Picture 1" descr="07-tooluse.png"/>
+          <p:cNvPr id="2" name="Picture 1" descr="07-cost.png"/>
           <p:cNvPicPr>
             <a:picLocks noChangeAspect="1"/>
           </p:cNvPicPr>
@@ -5971,7 +5974,7 @@
       <p:grpSpPr/>
       <p:pic>
         <p:nvPicPr>
-          <p:cNvPr id="2" name="Picture 1" descr="08-resilience.png"/>
+          <p:cNvPr id="2" name="Picture 1" descr="08-tooluse.png"/>
           <p:cNvPicPr>
             <a:picLocks noChangeAspect="1"/>
           </p:cNvPicPr>
@@ -6013,7 +6016,7 @@
       <p:grpSpPr/>
       <p:pic>
         <p:nvPicPr>
-          <p:cNvPr id="2" name="Picture 1" descr="09-security.png"/>
+          <p:cNvPr id="2" name="Picture 1" descr="09-resilience.png"/>
           <p:cNvPicPr>
             <a:picLocks noChangeAspect="1"/>
           </p:cNvPicPr>

</xml_diff>